<commit_message>
deck: slide 4 face shows only the two files the talk actually reads
Seven cards implied a seven-file walkthrough; the notes walk two. Face is now
showcase-discover-all.ts and pay.ts as two large cards with their one-line
promises, plus a quiet THE REST strip for the ordinary web code. Title becomes
Two files, lede says we read both line by line. 28 old card shapes dropped,
validated, rendered, inspected.

Co-Authored-By: Claude Opus 5 <noreply@anthropic.com>
</commit_message>
<xml_diff>
--- a/session-7/deck/MOI_Builders_S7new1f.pptx
+++ b/session-7/deck/MOI_Builders_S7new1f.pptx
@@ -4886,7 +4886,7 @@
                 <a:ea typeface="Inter" pitchFamily="34" charset="-122"/>
                 <a:cs typeface="Inter" pitchFamily="34" charset="-120"/>
               </a:rPr>
-              <a:t>Seven files</a:t>
+              <a:t>Two files</a:t>
             </a:r>
             <a:endParaRPr lang="en-US" sz="3800" dirty="0"/>
           </a:p>
@@ -4925,7 +4925,7 @@
                 <a:ea typeface="Inter" pitchFamily="34" charset="-122"/>
                 <a:cs typeface="Inter" pitchFamily="34" charset="-120"/>
               </a:rPr>
-              <a:t>Everything that makes the payment safe lives in these — and nowhere else.</a:t>
+              <a:t>Only two pieces of this touch MOI — and we'll read both, line by line.</a:t>
             </a:r>
             <a:endParaRPr lang="en-US" sz="1450" dirty="0"/>
           </a:p>
@@ -4933,18 +4933,18 @@
       </p:sp>
       <p:sp>
         <p:nvSpPr>
-          <p:cNvPr id="701" name="card701"/>
-          <p:cNvSpPr/>
-          <p:nvPr/>
-        </p:nvSpPr>
-        <p:spPr>
-          <a:xfrm>
-            <a:off x="822960" y="2121408"/>
-            <a:ext cx="5120640" cy="914400"/>
+          <p:cNvPr id="801" name="card801"/>
+          <p:cNvSpPr/>
+          <p:nvPr/>
+        </p:nvSpPr>
+        <p:spPr>
+          <a:xfrm>
+            <a:off x="822960" y="2240280"/>
+            <a:ext cx="5120640" cy="2286000"/>
           </a:xfrm>
           <a:prstGeom prst="roundRect">
             <a:avLst>
-              <a:gd name="adj" fmla="val 6500"/>
+              <a:gd name="adj" fmla="val 5000"/>
             </a:avLst>
           </a:prstGeom>
           <a:solidFill>
@@ -4966,14 +4966,14 @@
       </p:sp>
       <p:sp>
         <p:nvSpPr>
-          <p:cNvPr id="702" name="t702"/>
+          <p:cNvPr id="802" name="t802"/>
           <p:cNvSpPr txBox="1"/>
           <p:nvPr/>
         </p:nvSpPr>
         <p:spPr>
           <a:xfrm>
-            <a:off x="5074920" y="2212848"/>
-            <a:ext cx="594360" cy="256032"/>
+            <a:off x="5074920" y="2368296"/>
+            <a:ext cx="594360" cy="274320"/>
           </a:xfrm>
           <a:prstGeom prst="rect">
             <a:avLst/>
@@ -4986,7 +4986,7 @@
           <a:p>
             <a:pPr algn="r"/>
             <a:r>
-              <a:rPr lang="en-US" sz="1000" dirty="0">
+              <a:rPr lang="en-US" sz="1100" dirty="0">
                 <a:solidFill>
                   <a:srgbClr val="6B7280"/>
                 </a:solidFill>
@@ -4999,14 +4999,14 @@
       </p:sp>
       <p:sp>
         <p:nvSpPr>
-          <p:cNvPr id="703" name="t703"/>
+          <p:cNvPr id="803" name="t803"/>
           <p:cNvSpPr txBox="1"/>
           <p:nvPr/>
         </p:nvSpPr>
         <p:spPr>
           <a:xfrm>
-            <a:off x="1078992" y="2231136"/>
-            <a:ext cx="3886200" cy="292608"/>
+            <a:off x="1097280" y="2423160"/>
+            <a:ext cx="3886200" cy="329184"/>
           </a:xfrm>
           <a:prstGeom prst="rect">
             <a:avLst/>
@@ -5019,27 +5019,27 @@
           <a:p>
             <a:pPr algn="l"/>
             <a:r>
-              <a:rPr lang="en-US" sz="1400" b="1" dirty="0">
+              <a:rPr lang="en-US" sz="1500" b="1" dirty="0">
                 <a:solidFill>
                   <a:srgbClr val="FFFFFF"/>
                 </a:solidFill>
                 <a:latin typeface="Inter"/>
               </a:rPr>
-              <a:t>registry.ts</a:t>
-            </a:r>
-          </a:p>
-        </p:txBody>
-      </p:sp>
-      <p:sp>
-        <p:nvSpPr>
-          <p:cNvPr id="704" name="t704"/>
+              <a:t>showcase-discover-all.ts</a:t>
+            </a:r>
+          </a:p>
+        </p:txBody>
+      </p:sp>
+      <p:sp>
+        <p:nvSpPr>
+          <p:cNvPr id="804" name="t804"/>
           <p:cNvSpPr txBox="1"/>
           <p:nvPr/>
         </p:nvSpPr>
         <p:spPr>
           <a:xfrm>
-            <a:off x="1078992" y="2578608"/>
-            <a:ext cx="4608575" cy="402336"/>
+            <a:off x="1097280" y="2898648"/>
+            <a:ext cx="4572000" cy="1097280"/>
           </a:xfrm>
           <a:prstGeom prst="rect">
             <a:avLst/>
@@ -5052,31 +5052,64 @@
           <a:p>
             <a:pPr algn="l"/>
             <a:r>
-              <a:rPr lang="en-US" sz="1050" dirty="0">
+              <a:rPr lang="en-US" sz="1100" dirty="0">
                 <a:solidFill>
                   <a:srgbClr val="B9BECD"/>
                 </a:solidFill>
                 <a:latin typeface="Inter"/>
               </a:rPr>
-              <a:t>finds the seller — scans the on-chain agent cards for a skill tag, comes back with an id, a wallet and a URL</a:t>
-            </a:r>
-          </a:p>
-        </p:txBody>
-      </p:sp>
-      <p:sp>
-        <p:nvSpPr>
-          <p:cNvPr id="705" name="card705"/>
-          <p:cNvSpPr/>
-          <p:nvPr/>
-        </p:nvSpPr>
-        <p:spPr>
-          <a:xfrm>
-            <a:off x="6245352" y="2121408"/>
-            <a:ext cx="5120640" cy="914400"/>
+              <a:t>How the buyer finds a seller from nothing but a skill — walk the registry, open each agent's card, keep the tag match. In: a question. Out: an id, a wallet, and a URL.</a:t>
+            </a:r>
+          </a:p>
+        </p:txBody>
+      </p:sp>
+      <p:sp>
+        <p:nvSpPr>
+          <p:cNvPr id="805" name="t805"/>
+          <p:cNvSpPr txBox="1"/>
+          <p:nvPr/>
+        </p:nvSpPr>
+        <p:spPr>
+          <a:xfrm>
+            <a:off x="1097280" y="4142232"/>
+            <a:ext cx="4572000" cy="256032"/>
+          </a:xfrm>
+          <a:prstGeom prst="rect">
+            <a:avLst/>
+          </a:prstGeom>
+          <a:noFill/>
+        </p:spPr>
+        <p:txBody>
+          <a:bodyPr lIns="0" tIns="0" rIns="0" bIns="0"/>
+          <a:lstStyle/>
+          <a:p>
+            <a:pPr algn="l"/>
+            <a:r>
+              <a:rPr lang="en-US" sz="950" dirty="0">
+                <a:solidFill>
+                  <a:srgbClr val="8B8AF0"/>
+                </a:solidFill>
+                <a:latin typeface="JetBrains Mono"/>
+              </a:rPr>
+              <a:t>the discovery walk, line by line</a:t>
+            </a:r>
+          </a:p>
+        </p:txBody>
+      </p:sp>
+      <p:sp>
+        <p:nvSpPr>
+          <p:cNvPr id="806" name="card806"/>
+          <p:cNvSpPr/>
+          <p:nvPr/>
+        </p:nvSpPr>
+        <p:spPr>
+          <a:xfrm>
+            <a:off x="6245352" y="2240280"/>
+            <a:ext cx="5120640" cy="2286000"/>
           </a:xfrm>
           <a:prstGeom prst="roundRect">
             <a:avLst>
-              <a:gd name="adj" fmla="val 6500"/>
+              <a:gd name="adj" fmla="val 5000"/>
             </a:avLst>
           </a:prstGeom>
           <a:solidFill>
@@ -5098,14 +5131,14 @@
       </p:sp>
       <p:sp>
         <p:nvSpPr>
-          <p:cNvPr id="706" name="t706"/>
+          <p:cNvPr id="807" name="t807"/>
           <p:cNvSpPr txBox="1"/>
           <p:nvPr/>
         </p:nvSpPr>
         <p:spPr>
           <a:xfrm>
-            <a:off x="10497312" y="2212848"/>
-            <a:ext cx="594360" cy="256032"/>
+            <a:off x="10497312" y="2368296"/>
+            <a:ext cx="594360" cy="274320"/>
           </a:xfrm>
           <a:prstGeom prst="rect">
             <a:avLst/>
@@ -5118,7 +5151,7 @@
           <a:p>
             <a:pPr algn="r"/>
             <a:r>
-              <a:rPr lang="en-US" sz="1000" dirty="0">
+              <a:rPr lang="en-US" sz="1100" dirty="0">
                 <a:solidFill>
                   <a:srgbClr val="6B7280"/>
                 </a:solidFill>
@@ -5131,14 +5164,14 @@
       </p:sp>
       <p:sp>
         <p:nvSpPr>
-          <p:cNvPr id="707" name="t707"/>
+          <p:cNvPr id="808" name="t808"/>
           <p:cNvSpPr txBox="1"/>
           <p:nvPr/>
         </p:nvSpPr>
         <p:spPr>
           <a:xfrm>
-            <a:off x="6501384" y="2231136"/>
-            <a:ext cx="3886200" cy="292608"/>
+            <a:off x="6519672" y="2423160"/>
+            <a:ext cx="3886200" cy="329184"/>
           </a:xfrm>
           <a:prstGeom prst="rect">
             <a:avLst/>
@@ -5151,27 +5184,27 @@
           <a:p>
             <a:pPr algn="l"/>
             <a:r>
-              <a:rPr lang="en-US" sz="1400" b="1" dirty="0">
+              <a:rPr lang="en-US" sz="1500" b="1" dirty="0">
                 <a:solidFill>
                   <a:srgbClr val="FFFFFF"/>
                 </a:solidFill>
                 <a:latin typeface="Inter"/>
               </a:rPr>
-              <a:t>index.ts</a:t>
-            </a:r>
-          </a:p>
-        </p:txBody>
-      </p:sp>
-      <p:sp>
-        <p:nvSpPr>
-          <p:cNvPr id="708" name="t708"/>
+              <a:t>pay.ts</a:t>
+            </a:r>
+          </a:p>
+        </p:txBody>
+      </p:sp>
+      <p:sp>
+        <p:nvSpPr>
+          <p:cNvPr id="809" name="t809"/>
           <p:cNvSpPr txBox="1"/>
           <p:nvPr/>
         </p:nvSpPr>
         <p:spPr>
           <a:xfrm>
-            <a:off x="6501384" y="2578608"/>
-            <a:ext cx="4608575" cy="402336"/>
+            <a:off x="6519672" y="2898648"/>
+            <a:ext cx="4572000" cy="1097280"/>
           </a:xfrm>
           <a:prstGeom prst="rect">
             <a:avLst/>
@@ -5184,35 +5217,68 @@
           <a:p>
             <a:pPr algn="l"/>
             <a:r>
-              <a:rPr lang="en-US" sz="1050" dirty="0">
+              <a:rPr lang="en-US" sz="1100" dirty="0">
                 <a:solidFill>
                   <a:srgbClr val="B9BECD"/>
                 </a:solidFill>
                 <a:latin typeface="Inter"/>
               </a:rPr>
-              <a:t>the shopfront — a plain web server: the catalog is free to browse, the answer sits behind a paywall</a:t>
-            </a:r>
-          </a:p>
-        </p:txBody>
-      </p:sp>
-      <p:sp>
-        <p:nvSpPr>
-          <p:cNvPr id="709" name="card709"/>
-          <p:cNvSpPr/>
-          <p:nvPr/>
-        </p:nvSpPr>
-        <p:spPr>
-          <a:xfrm>
-            <a:off x="822960" y="3145536"/>
-            <a:ext cx="5120640" cy="914400"/>
+              <a:t>How an agent hands over money — one signature moves the funds on MOI, and a second one proves that payment belongs to this purchase. The buyer pushes; the seller never pulls.</a:t>
+            </a:r>
+          </a:p>
+        </p:txBody>
+      </p:sp>
+      <p:sp>
+        <p:nvSpPr>
+          <p:cNvPr id="810" name="t810"/>
+          <p:cNvSpPr txBox="1"/>
+          <p:nvPr/>
+        </p:nvSpPr>
+        <p:spPr>
+          <a:xfrm>
+            <a:off x="6519672" y="4142232"/>
+            <a:ext cx="4572000" cy="256032"/>
+          </a:xfrm>
+          <a:prstGeom prst="rect">
+            <a:avLst/>
+          </a:prstGeom>
+          <a:noFill/>
+        </p:spPr>
+        <p:txBody>
+          <a:bodyPr lIns="0" tIns="0" rIns="0" bIns="0"/>
+          <a:lstStyle/>
+          <a:p>
+            <a:pPr algn="l"/>
+            <a:r>
+              <a:rPr lang="en-US" sz="950" dirty="0">
+                <a:solidFill>
+                  <a:srgbClr val="8B8AF0"/>
+                </a:solidFill>
+                <a:latin typeface="JetBrains Mono"/>
+              </a:rPr>
+              <a:t>two signatures, line by line</a:t>
+            </a:r>
+          </a:p>
+        </p:txBody>
+      </p:sp>
+      <p:sp>
+        <p:nvSpPr>
+          <p:cNvPr id="811" name="card811"/>
+          <p:cNvSpPr/>
+          <p:nvPr/>
+        </p:nvSpPr>
+        <p:spPr>
+          <a:xfrm>
+            <a:off x="822960" y="4800600"/>
+            <a:ext cx="10543032" cy="896112"/>
           </a:xfrm>
           <a:prstGeom prst="roundRect">
             <a:avLst>
-              <a:gd name="adj" fmla="val 6500"/>
+              <a:gd name="adj" fmla="val 5000"/>
             </a:avLst>
           </a:prstGeom>
           <a:solidFill>
-            <a:srgbClr val="141821"/>
+            <a:srgbClr val="0C0F14"/>
           </a:solidFill>
           <a:ln w="12700">
             <a:solidFill>
@@ -5230,14 +5296,14 @@
       </p:sp>
       <p:sp>
         <p:nvSpPr>
-          <p:cNvPr id="710" name="t710"/>
+          <p:cNvPr id="812" name="t812"/>
           <p:cNvSpPr txBox="1"/>
           <p:nvPr/>
         </p:nvSpPr>
         <p:spPr>
           <a:xfrm>
-            <a:off x="5074920" y="3236976"/>
-            <a:ext cx="594360" cy="256032"/>
+            <a:off x="1097280" y="4946904"/>
+            <a:ext cx="2194560" cy="237744"/>
           </a:xfrm>
           <a:prstGeom prst="rect">
             <a:avLst/>
@@ -5248,29 +5314,29 @@
           <a:bodyPr lIns="0" tIns="0" rIns="0" bIns="0"/>
           <a:lstStyle/>
           <a:p>
-            <a:pPr algn="r"/>
-            <a:r>
-              <a:rPr lang="en-US" sz="1000" dirty="0">
+            <a:pPr algn="l"/>
+            <a:r>
+              <a:rPr lang="en-US" sz="1000" spc="130" dirty="0">
                 <a:solidFill>
                   <a:srgbClr val="6B7280"/>
                 </a:solidFill>
                 <a:latin typeface="JetBrains Mono"/>
               </a:rPr>
-              <a:t>03</a:t>
-            </a:r>
-          </a:p>
-        </p:txBody>
-      </p:sp>
-      <p:sp>
-        <p:nvSpPr>
-          <p:cNvPr id="711" name="t711"/>
+              <a:t>THE REST</a:t>
+            </a:r>
+          </a:p>
+        </p:txBody>
+      </p:sp>
+      <p:sp>
+        <p:nvSpPr>
+          <p:cNvPr id="813" name="t813"/>
           <p:cNvSpPr txBox="1"/>
           <p:nvPr/>
         </p:nvSpPr>
         <p:spPr>
           <a:xfrm>
-            <a:off x="1078992" y="3255264"/>
-            <a:ext cx="3886200" cy="292608"/>
+            <a:off x="1097280" y="5221224"/>
+            <a:ext cx="9994392" cy="365760"/>
           </a:xfrm>
           <a:prstGeom prst="rect">
             <a:avLst/>
@@ -5283,574 +5349,13 @@
           <a:p>
             <a:pPr algn="l"/>
             <a:r>
-              <a:rPr lang="en-US" sz="1400" b="1" dirty="0">
-                <a:solidFill>
-                  <a:srgbClr val="FFFFFF"/>
+              <a:rPr lang="en-US" sz="1050" dirty="0">
+                <a:solidFill>
+                  <a:srgbClr val="B9BECD"/>
                 </a:solidFill>
                 <a:latin typeface="Inter"/>
               </a:rPr>
-              <a:t>paywall.ts</a:t>
-            </a:r>
-          </a:p>
-        </p:txBody>
-      </p:sp>
-      <p:sp>
-        <p:nvSpPr>
-          <p:cNvPr id="712" name="t712"/>
-          <p:cNvSpPr txBox="1"/>
-          <p:nvPr/>
-        </p:nvSpPr>
-        <p:spPr>
-          <a:xfrm>
-            <a:off x="1078992" y="3602736"/>
-            <a:ext cx="4608575" cy="402336"/>
-          </a:xfrm>
-          <a:prstGeom prst="rect">
-            <a:avLst/>
-          </a:prstGeom>
-          <a:noFill/>
-        </p:spPr>
-        <p:txBody>
-          <a:bodyPr lIns="0" tIns="0" rIns="0" bIns="0"/>
-          <a:lstStyle/>
-          <a:p>
-            <a:pPr algn="l"/>
-            <a:r>
-              <a:rPr lang="en-US" sz="1050" dirty="0">
-                <a:solidFill>
-                  <a:srgbClr val="B9BECD"/>
-                </a:solidFill>
-                <a:latin typeface="Inter"/>
-              </a:rPr>
-              <a:t>the tollgate — no proof of payment? reply 402 with a quote. proof checks out? ship the answer</a:t>
-            </a:r>
-          </a:p>
-        </p:txBody>
-      </p:sp>
-      <p:sp>
-        <p:nvSpPr>
-          <p:cNvPr id="713" name="card713"/>
-          <p:cNvSpPr/>
-          <p:nvPr/>
-        </p:nvSpPr>
-        <p:spPr>
-          <a:xfrm>
-            <a:off x="6245352" y="3145536"/>
-            <a:ext cx="5120640" cy="914400"/>
-          </a:xfrm>
-          <a:prstGeom prst="roundRect">
-            <a:avLst>
-              <a:gd name="adj" fmla="val 6500"/>
-            </a:avLst>
-          </a:prstGeom>
-          <a:solidFill>
-            <a:srgbClr val="141821"/>
-          </a:solidFill>
-          <a:ln w="12700">
-            <a:solidFill>
-              <a:srgbClr val="2A2E37"/>
-            </a:solidFill>
-          </a:ln>
-        </p:spPr>
-        <p:txBody>
-          <a:bodyPr/>
-          <a:lstStyle/>
-          <a:p>
-            <a:endParaRPr lang="en-US"/>
-          </a:p>
-        </p:txBody>
-      </p:sp>
-      <p:sp>
-        <p:nvSpPr>
-          <p:cNvPr id="714" name="t714"/>
-          <p:cNvSpPr txBox="1"/>
-          <p:nvPr/>
-        </p:nvSpPr>
-        <p:spPr>
-          <a:xfrm>
-            <a:off x="10497312" y="3236976"/>
-            <a:ext cx="594360" cy="256032"/>
-          </a:xfrm>
-          <a:prstGeom prst="rect">
-            <a:avLst/>
-          </a:prstGeom>
-          <a:noFill/>
-        </p:spPr>
-        <p:txBody>
-          <a:bodyPr lIns="0" tIns="0" rIns="0" bIns="0"/>
-          <a:lstStyle/>
-          <a:p>
-            <a:pPr algn="r"/>
-            <a:r>
-              <a:rPr lang="en-US" sz="1000" dirty="0">
-                <a:solidFill>
-                  <a:srgbClr val="6B7280"/>
-                </a:solidFill>
-                <a:latin typeface="JetBrains Mono"/>
-              </a:rPr>
-              <a:t>04</a:t>
-            </a:r>
-          </a:p>
-        </p:txBody>
-      </p:sp>
-      <p:sp>
-        <p:nvSpPr>
-          <p:cNvPr id="715" name="t715"/>
-          <p:cNvSpPr txBox="1"/>
-          <p:nvPr/>
-        </p:nvSpPr>
-        <p:spPr>
-          <a:xfrm>
-            <a:off x="6501384" y="3255264"/>
-            <a:ext cx="3886200" cy="292608"/>
-          </a:xfrm>
-          <a:prstGeom prst="rect">
-            <a:avLst/>
-          </a:prstGeom>
-          <a:noFill/>
-        </p:spPr>
-        <p:txBody>
-          <a:bodyPr lIns="0" tIns="0" rIns="0" bIns="0"/>
-          <a:lstStyle/>
-          <a:p>
-            <a:pPr algn="l"/>
-            <a:r>
-              <a:rPr lang="en-US" sz="1400" b="1" dirty="0">
-                <a:solidFill>
-                  <a:srgbClr val="FFFFFF"/>
-                </a:solidFill>
-                <a:latin typeface="Inter"/>
-              </a:rPr>
-              <a:t>pricing.ts + worth.ts</a:t>
-            </a:r>
-          </a:p>
-        </p:txBody>
-      </p:sp>
-      <p:sp>
-        <p:nvSpPr>
-          <p:cNvPr id="716" name="t716"/>
-          <p:cNvSpPr txBox="1"/>
-          <p:nvPr/>
-        </p:nvSpPr>
-        <p:spPr>
-          <a:xfrm>
-            <a:off x="6501384" y="3602736"/>
-            <a:ext cx="4608575" cy="402336"/>
-          </a:xfrm>
-          <a:prstGeom prst="rect">
-            <a:avLst/>
-          </a:prstGeom>
-          <a:noFill/>
-        </p:spPr>
-        <p:txBody>
-          <a:bodyPr lIns="0" tIns="0" rIns="0" bIns="0"/>
-          <a:lstStyle/>
-          <a:p>
-            <a:pPr algn="l"/>
-            <a:r>
-              <a:rPr lang="en-US" sz="1050" dirty="0">
-                <a:solidFill>
-                  <a:srgbClr val="B9BECD"/>
-                </a:solidFill>
-                <a:latin typeface="Inter"/>
-              </a:rPr>
-              <a:t>the money brains — seller decides what to charge, buyer decides if it's worth it, inside bounds neither model controls</a:t>
-            </a:r>
-          </a:p>
-        </p:txBody>
-      </p:sp>
-      <p:sp>
-        <p:nvSpPr>
-          <p:cNvPr id="717" name="card717"/>
-          <p:cNvSpPr/>
-          <p:nvPr/>
-        </p:nvSpPr>
-        <p:spPr>
-          <a:xfrm>
-            <a:off x="822960" y="4169664"/>
-            <a:ext cx="5120640" cy="914400"/>
-          </a:xfrm>
-          <a:prstGeom prst="roundRect">
-            <a:avLst>
-              <a:gd name="adj" fmla="val 6500"/>
-            </a:avLst>
-          </a:prstGeom>
-          <a:solidFill>
-            <a:srgbClr val="0C1A15"/>
-          </a:solidFill>
-          <a:ln w="12700">
-            <a:solidFill>
-              <a:srgbClr val="3CCB8E"/>
-            </a:solidFill>
-          </a:ln>
-        </p:spPr>
-        <p:txBody>
-          <a:bodyPr/>
-          <a:lstStyle/>
-          <a:p>
-            <a:endParaRPr lang="en-US"/>
-          </a:p>
-        </p:txBody>
-      </p:sp>
-      <p:sp>
-        <p:nvSpPr>
-          <p:cNvPr id="718" name="t718"/>
-          <p:cNvSpPr txBox="1"/>
-          <p:nvPr/>
-        </p:nvSpPr>
-        <p:spPr>
-          <a:xfrm>
-            <a:off x="5074920" y="4261104"/>
-            <a:ext cx="594360" cy="256032"/>
-          </a:xfrm>
-          <a:prstGeom prst="rect">
-            <a:avLst/>
-          </a:prstGeom>
-          <a:noFill/>
-        </p:spPr>
-        <p:txBody>
-          <a:bodyPr lIns="0" tIns="0" rIns="0" bIns="0"/>
-          <a:lstStyle/>
-          <a:p>
-            <a:pPr algn="r"/>
-            <a:r>
-              <a:rPr lang="en-US" sz="1000" dirty="0">
-                <a:solidFill>
-                  <a:srgbClr val="6B7280"/>
-                </a:solidFill>
-                <a:latin typeface="JetBrains Mono"/>
-              </a:rPr>
-              <a:t>05</a:t>
-            </a:r>
-          </a:p>
-        </p:txBody>
-      </p:sp>
-      <p:sp>
-        <p:nvSpPr>
-          <p:cNvPr id="719" name="t719"/>
-          <p:cNvSpPr txBox="1"/>
-          <p:nvPr/>
-        </p:nvSpPr>
-        <p:spPr>
-          <a:xfrm>
-            <a:off x="1078992" y="4279392"/>
-            <a:ext cx="3886200" cy="292608"/>
-          </a:xfrm>
-          <a:prstGeom prst="rect">
-            <a:avLst/>
-          </a:prstGeom>
-          <a:noFill/>
-        </p:spPr>
-        <p:txBody>
-          <a:bodyPr lIns="0" tIns="0" rIns="0" bIns="0"/>
-          <a:lstStyle/>
-          <a:p>
-            <a:pPr algn="l"/>
-            <a:r>
-              <a:rPr lang="en-US" sz="1400" b="1" dirty="0">
-                <a:solidFill>
-                  <a:srgbClr val="3CCB8E"/>
-                </a:solidFill>
-                <a:latin typeface="Inter"/>
-              </a:rPr>
-              <a:t>identity-check.ts</a:t>
-            </a:r>
-          </a:p>
-        </p:txBody>
-      </p:sp>
-      <p:sp>
-        <p:nvSpPr>
-          <p:cNvPr id="720" name="t720"/>
-          <p:cNvSpPr txBox="1"/>
-          <p:nvPr/>
-        </p:nvSpPr>
-        <p:spPr>
-          <a:xfrm>
-            <a:off x="1078992" y="4626864"/>
-            <a:ext cx="4608575" cy="402336"/>
-          </a:xfrm>
-          <a:prstGeom prst="rect">
-            <a:avLst/>
-          </a:prstGeom>
-          <a:noFill/>
-        </p:spPr>
-        <p:txBody>
-          <a:bodyPr lIns="0" tIns="0" rIns="0" bIns="0"/>
-          <a:lstStyle/>
-          <a:p>
-            <a:pPr algn="l"/>
-            <a:r>
-              <a:rPr lang="en-US" sz="1050" dirty="0">
-                <a:solidFill>
-                  <a:srgbClr val="B9BECD"/>
-                </a:solidFill>
-                <a:latin typeface="Inter"/>
-              </a:rPr>
-              <a:t>the heart of it — before paying: is this address really the wallet this agent registered on chain? mismatch, refuse</a:t>
-            </a:r>
-          </a:p>
-        </p:txBody>
-      </p:sp>
-      <p:sp>
-        <p:nvSpPr>
-          <p:cNvPr id="721" name="card721"/>
-          <p:cNvSpPr/>
-          <p:nvPr/>
-        </p:nvSpPr>
-        <p:spPr>
-          <a:xfrm>
-            <a:off x="6245352" y="4169664"/>
-            <a:ext cx="5120640" cy="914400"/>
-          </a:xfrm>
-          <a:prstGeom prst="roundRect">
-            <a:avLst>
-              <a:gd name="adj" fmla="val 6500"/>
-            </a:avLst>
-          </a:prstGeom>
-          <a:solidFill>
-            <a:srgbClr val="141821"/>
-          </a:solidFill>
-          <a:ln w="12700">
-            <a:solidFill>
-              <a:srgbClr val="2A2E37"/>
-            </a:solidFill>
-          </a:ln>
-        </p:spPr>
-        <p:txBody>
-          <a:bodyPr/>
-          <a:lstStyle/>
-          <a:p>
-            <a:endParaRPr lang="en-US"/>
-          </a:p>
-        </p:txBody>
-      </p:sp>
-      <p:sp>
-        <p:nvSpPr>
-          <p:cNvPr id="722" name="t722"/>
-          <p:cNvSpPr txBox="1"/>
-          <p:nvPr/>
-        </p:nvSpPr>
-        <p:spPr>
-          <a:xfrm>
-            <a:off x="10497312" y="4261104"/>
-            <a:ext cx="594360" cy="256032"/>
-          </a:xfrm>
-          <a:prstGeom prst="rect">
-            <a:avLst/>
-          </a:prstGeom>
-          <a:noFill/>
-        </p:spPr>
-        <p:txBody>
-          <a:bodyPr lIns="0" tIns="0" rIns="0" bIns="0"/>
-          <a:lstStyle/>
-          <a:p>
-            <a:pPr algn="r"/>
-            <a:r>
-              <a:rPr lang="en-US" sz="1000" dirty="0">
-                <a:solidFill>
-                  <a:srgbClr val="6B7280"/>
-                </a:solidFill>
-                <a:latin typeface="JetBrains Mono"/>
-              </a:rPr>
-              <a:t>06</a:t>
-            </a:r>
-          </a:p>
-        </p:txBody>
-      </p:sp>
-      <p:sp>
-        <p:nvSpPr>
-          <p:cNvPr id="723" name="t723"/>
-          <p:cNvSpPr txBox="1"/>
-          <p:nvPr/>
-        </p:nvSpPr>
-        <p:spPr>
-          <a:xfrm>
-            <a:off x="6501384" y="4279392"/>
-            <a:ext cx="3886200" cy="292608"/>
-          </a:xfrm>
-          <a:prstGeom prst="rect">
-            <a:avLst/>
-          </a:prstGeom>
-          <a:noFill/>
-        </p:spPr>
-        <p:txBody>
-          <a:bodyPr lIns="0" tIns="0" rIns="0" bIns="0"/>
-          <a:lstStyle/>
-          <a:p>
-            <a:pPr algn="l"/>
-            <a:r>
-              <a:rPr lang="en-US" sz="1400" b="1" dirty="0">
-                <a:solidFill>
-                  <a:srgbClr val="FFFFFF"/>
-                </a:solidFill>
-                <a:latin typeface="Inter"/>
-              </a:rPr>
-              <a:t>pay.ts</a:t>
-            </a:r>
-          </a:p>
-        </p:txBody>
-      </p:sp>
-      <p:sp>
-        <p:nvSpPr>
-          <p:cNvPr id="724" name="t724"/>
-          <p:cNvSpPr txBox="1"/>
-          <p:nvPr/>
-        </p:nvSpPr>
-        <p:spPr>
-          <a:xfrm>
-            <a:off x="6501384" y="4626864"/>
-            <a:ext cx="4608575" cy="402336"/>
-          </a:xfrm>
-          <a:prstGeom prst="rect">
-            <a:avLst/>
-          </a:prstGeom>
-          <a:noFill/>
-        </p:spPr>
-        <p:txBody>
-          <a:bodyPr lIns="0" tIns="0" rIns="0" bIns="0"/>
-          <a:lstStyle/>
-          <a:p>
-            <a:pPr algn="l"/>
-            <a:r>
-              <a:rPr lang="en-US" sz="1050" dirty="0">
-                <a:solidFill>
-                  <a:srgbClr val="B9BECD"/>
-                </a:solidFill>
-                <a:latin typeface="Inter"/>
-              </a:rPr>
-              <a:t>the payment — pays from the agent's own wallet, signs a claim naming that transaction, retries with proof attached</a:t>
-            </a:r>
-          </a:p>
-        </p:txBody>
-      </p:sp>
-      <p:sp>
-        <p:nvSpPr>
-          <p:cNvPr id="725" name="card725"/>
-          <p:cNvSpPr/>
-          <p:nvPr/>
-        </p:nvSpPr>
-        <p:spPr>
-          <a:xfrm>
-            <a:off x="822960" y="5193792"/>
-            <a:ext cx="10543032" cy="914400"/>
-          </a:xfrm>
-          <a:prstGeom prst="roundRect">
-            <a:avLst>
-              <a:gd name="adj" fmla="val 6500"/>
-            </a:avLst>
-          </a:prstGeom>
-          <a:solidFill>
-            <a:srgbClr val="141821"/>
-          </a:solidFill>
-          <a:ln w="12700">
-            <a:solidFill>
-              <a:srgbClr val="2A2E37"/>
-            </a:solidFill>
-          </a:ln>
-        </p:spPr>
-        <p:txBody>
-          <a:bodyPr/>
-          <a:lstStyle/>
-          <a:p>
-            <a:endParaRPr lang="en-US"/>
-          </a:p>
-        </p:txBody>
-      </p:sp>
-      <p:sp>
-        <p:nvSpPr>
-          <p:cNvPr id="726" name="t726"/>
-          <p:cNvSpPr txBox="1"/>
-          <p:nvPr/>
-        </p:nvSpPr>
-        <p:spPr>
-          <a:xfrm>
-            <a:off x="10497312" y="5285231"/>
-            <a:ext cx="594360" cy="256032"/>
-          </a:xfrm>
-          <a:prstGeom prst="rect">
-            <a:avLst/>
-          </a:prstGeom>
-          <a:noFill/>
-        </p:spPr>
-        <p:txBody>
-          <a:bodyPr lIns="0" tIns="0" rIns="0" bIns="0"/>
-          <a:lstStyle/>
-          <a:p>
-            <a:pPr algn="r"/>
-            <a:r>
-              <a:rPr lang="en-US" sz="1000" dirty="0">
-                <a:solidFill>
-                  <a:srgbClr val="6B7280"/>
-                </a:solidFill>
-                <a:latin typeface="JetBrains Mono"/>
-              </a:rPr>
-              <a:t>07</a:t>
-            </a:r>
-          </a:p>
-        </p:txBody>
-      </p:sp>
-      <p:sp>
-        <p:nvSpPr>
-          <p:cNvPr id="727" name="t727"/>
-          <p:cNvSpPr txBox="1"/>
-          <p:nvPr/>
-        </p:nvSpPr>
-        <p:spPr>
-          <a:xfrm>
-            <a:off x="1078992" y="5303520"/>
-            <a:ext cx="9308592" cy="292608"/>
-          </a:xfrm>
-          <a:prstGeom prst="rect">
-            <a:avLst/>
-          </a:prstGeom>
-          <a:noFill/>
-        </p:spPr>
-        <p:txBody>
-          <a:bodyPr lIns="0" tIns="0" rIns="0" bIns="0"/>
-          <a:lstStyle/>
-          <a:p>
-            <a:pPr algn="l"/>
-            <a:r>
-              <a:rPr lang="en-US" sz="1400" b="1" dirty="0">
-                <a:solidFill>
-                  <a:srgbClr val="FFFFFF"/>
-                </a:solidFill>
-                <a:latin typeface="Inter"/>
-              </a:rPr>
-              <a:t>verify-proof.ts</a:t>
-            </a:r>
-          </a:p>
-        </p:txBody>
-      </p:sp>
-      <p:sp>
-        <p:nvSpPr>
-          <p:cNvPr id="728" name="t728"/>
-          <p:cNvSpPr txBox="1"/>
-          <p:nvPr/>
-        </p:nvSpPr>
-        <p:spPr>
-          <a:xfrm>
-            <a:off x="1078992" y="5650992"/>
-            <a:ext cx="10030967" cy="402336"/>
-          </a:xfrm>
-          <a:prstGeom prst="rect">
-            <a:avLst/>
-          </a:prstGeom>
-          <a:noFill/>
-        </p:spPr>
-        <p:txBody>
-          <a:bodyPr lIns="0" tIns="0" rIns="0" bIns="0"/>
-          <a:lstStyle/>
-          <a:p>
-            <a:pPr algn="l"/>
-            <a:r>
-              <a:rPr lang="en-US" sz="1050" dirty="0">
-                <a:solidFill>
-                  <a:srgbClr val="B9BECD"/>
-                </a:solidFill>
-                <a:latin typeface="Inter"/>
-              </a:rPr>
-              <a:t>the seller's seven checks — signature, payer identity, amount, expiry, replay, and the transfer itself, read off the chain rather than taken on the buyer's word</a:t>
+              <a:t>Ordinary web code — a small server with a free catalog, a 402 paywall, seven read-only checks, and two model brains that never touch the chain.</a:t>
             </a:r>
           </a:p>
         </p:txBody>

</xml_diff>